<commit_message>
docs: refine proposal presentation transitions
</commit_message>
<xml_diff>
--- a/documents/IIT_Search_Engine_SPL1_Proposal_Rifat_Al_Maruf_Prototype.pptx
+++ b/documents/IIT_Search_Engine_SPL1_Proposal_Rifat_Al_Maruf_Prototype.pptx
@@ -111,6 +111,11 @@
       </a:defRPr>
     </a:lvl9pPr>
   </p:defaultTextStyle>
+  <p:extLst>
+    <p:ext uri="{EFAFB233-063F-42B5-8137-9DF3F51BA10A}">
+      <p15:sldGuideLst xmlns:p15="http://schemas.microsoft.com/office/powerpoint/2012/main"/>
+    </p:ext>
+  </p:extLst>
 </p:presentation>
 </file>
 
@@ -2093,6 +2098,18 @@
   <p:clrMapOvr>
     <a:masterClrMapping/>
   </p:clrMapOvr>
+  <mc:AlternateContent xmlns:mc="http://schemas.openxmlformats.org/markup-compatibility/2006">
+    <mc:Choice xmlns:p14="http://schemas.microsoft.com/office/powerpoint/2010/main" Requires="p14">
+      <p:transition spd="slow" p14:dur="800">
+        <p14:flythrough/>
+      </p:transition>
+    </mc:Choice>
+    <mc:Fallback>
+      <p:transition spd="slow">
+        <p:fade/>
+      </p:transition>
+    </mc:Fallback>
+  </mc:AlternateContent>
 </p:sld>
 </file>
 
@@ -2166,7 +2183,7 @@
               </a:defRPr>
             </a:pPr>
             <a:r>
-              <a:rPr sz="2700" b="1">
+              <a:rPr sz="2700" b="1" dirty="0">
                 <a:solidFill>
                   <a:srgbClr val="17324D"/>
                 </a:solidFill>
@@ -3335,6 +3352,18 @@
   <p:clrMapOvr>
     <a:masterClrMapping/>
   </p:clrMapOvr>
+  <mc:AlternateContent xmlns:mc="http://schemas.openxmlformats.org/markup-compatibility/2006">
+    <mc:Choice xmlns:p14="http://schemas.microsoft.com/office/powerpoint/2010/main" Requires="p14">
+      <p:transition spd="slow" p14:dur="900">
+        <p14:flythrough hasBounce="1"/>
+      </p:transition>
+    </mc:Choice>
+    <mc:Fallback>
+      <p:transition spd="slow">
+        <p:fade/>
+      </p:transition>
+    </mc:Fallback>
+  </mc:AlternateContent>
 </p:sld>
 </file>
 
@@ -5459,6 +5488,18 @@
   <p:clrMapOvr>
     <a:masterClrMapping/>
   </p:clrMapOvr>
+  <mc:AlternateContent xmlns:mc="http://schemas.openxmlformats.org/markup-compatibility/2006">
+    <mc:Choice xmlns:p14="http://schemas.microsoft.com/office/powerpoint/2010/main" Requires="p14">
+      <p:transition spd="slow">
+        <p14:window dir="vert"/>
+      </p:transition>
+    </mc:Choice>
+    <mc:Fallback>
+      <p:transition spd="slow">
+        <p:fade/>
+      </p:transition>
+    </mc:Fallback>
+  </mc:AlternateContent>
 </p:sld>
 </file>
 
@@ -7090,6 +7131,18 @@
   <p:clrMapOvr>
     <a:masterClrMapping/>
   </p:clrMapOvr>
+  <mc:AlternateContent xmlns:mc="http://schemas.openxmlformats.org/markup-compatibility/2006">
+    <mc:Choice xmlns:p159="http://schemas.microsoft.com/office/powerpoint/2015/09/main" Requires="p159">
+      <p:transition spd="slow">
+        <p159:morph option="byObject"/>
+      </p:transition>
+    </mc:Choice>
+    <mc:Fallback>
+      <p:transition spd="slow">
+        <p:fade/>
+      </p:transition>
+    </mc:Fallback>
+  </mc:AlternateContent>
 </p:sld>
 </file>
 
@@ -9131,7 +9184,7 @@
         </p:nvPicPr>
         <p:blipFill>
           <a:blip r:embed="rId3"/>
-          <a:srcRect l="0" t="48323" r="4762" b="9073"/>
+          <a:srcRect t="48323" r="4762" b="9073"/>
           <a:stretch>
             <a:fillRect/>
           </a:stretch>
@@ -9214,6 +9267,18 @@
   <p:clrMapOvr>
     <a:masterClrMapping/>
   </p:clrMapOvr>
+  <mc:AlternateContent xmlns:mc="http://schemas.openxmlformats.org/markup-compatibility/2006">
+    <mc:Choice xmlns:p159="http://schemas.microsoft.com/office/powerpoint/2015/09/main" Requires="p159">
+      <p:transition spd="slow">
+        <p159:morph option="byObject"/>
+      </p:transition>
+    </mc:Choice>
+    <mc:Fallback>
+      <p:transition spd="slow">
+        <p:fade/>
+      </p:transition>
+    </mc:Fallback>
+  </mc:AlternateContent>
 </p:sld>
 </file>
 

</xml_diff>